<commit_message>
Updated ROS2 slides with corrections and memes xx
</commit_message>
<xml_diff>
--- a/ROS2/ROS2_TurtleBot_Gazebo_Workshop.pptx
+++ b/ROS2/ROS2_TurtleBot_Gazebo_Workshop.pptx
@@ -3291,18 +3291,84 @@
           </a:p>
         </p:txBody>
       </p:sp>
+      <p:pic>
+        <p:nvPicPr>
+          <p:cNvPr id="16" name="Picture 15">
+            <a:extLst>
+              <a:ext uri="{FF2B5EF4-FFF2-40B4-BE49-F238E27FC236}">
+                <a16:creationId xmlns:a16="http://schemas.microsoft.com/office/drawing/2014/main" id="{7D0B1DC1-6210-B190-D21F-8B0BD2562DA6}"/>
+              </a:ext>
+            </a:extLst>
+          </p:cNvPr>
+          <p:cNvPicPr>
+            <a:picLocks noChangeAspect="1"/>
+          </p:cNvPicPr>
+          <p:nvPr/>
+        </p:nvPicPr>
+        <p:blipFill>
+          <a:blip r:embed="rId3"/>
+          <a:srcRect/>
+          <a:stretch>
+            <a:fillRect/>
+          </a:stretch>
+        </p:blipFill>
+        <p:spPr>
+          <a:xfrm>
+            <a:off x="8220973" y="1900506"/>
+            <a:ext cx="2583611" cy="2557194"/>
+          </a:xfrm>
+          <a:prstGeom prst="rect">
+            <a:avLst/>
+          </a:prstGeom>
+        </p:spPr>
+      </p:pic>
+      <p:sp>
+        <p:nvSpPr>
+          <p:cNvPr id="24" name="TextBox 23">
+            <a:extLst>
+              <a:ext uri="{FF2B5EF4-FFF2-40B4-BE49-F238E27FC236}">
+                <a16:creationId xmlns:a16="http://schemas.microsoft.com/office/drawing/2014/main" id="{5773D9E4-35AC-07AB-2566-DF13955CE98F}"/>
+              </a:ext>
+            </a:extLst>
+          </p:cNvPr>
+          <p:cNvSpPr txBox="1"/>
+          <p:nvPr/>
+        </p:nvSpPr>
+        <p:spPr>
+          <a:xfrm>
+            <a:off x="9329074" y="3408700"/>
+            <a:ext cx="367408" cy="523220"/>
+          </a:xfrm>
+          <a:prstGeom prst="rect">
+            <a:avLst/>
+          </a:prstGeom>
+          <a:noFill/>
+        </p:spPr>
+        <p:txBody>
+          <a:bodyPr wrap="none" rtlCol="0">
+            <a:spAutoFit/>
+          </a:bodyPr>
+          <a:lstStyle/>
+          <a:p>
+            <a:r>
+              <a:rPr lang="en-AU" sz="2800" dirty="0"/>
+              <a:t>3</a:t>
+            </a:r>
+          </a:p>
+        </p:txBody>
+      </p:sp>
     </p:spTree>
   </p:cSld>
   <p:clrMapOvr>
     <a:masterClrMapping/>
   </p:clrMapOvr>
-  <mc:AlternateContent xmlns:mc="http://schemas.openxmlformats.org/markup-compatibility/2006">
-    <mc:Choice xmlns:p159="http://schemas.microsoft.com/office/powerpoint/2015/09/main" Requires="p159">
+  <mc:AlternateContent xmlns:mc="http://schemas.openxmlformats.org/markup-compatibility/2006" xmlns:p159="http://schemas.microsoft.com/office/powerpoint/2015/09/main">
+    <mc:Choice Requires="p159">
       <p:transition xmlns:p14="http://schemas.microsoft.com/office/powerpoint/2010/main" spd="slow" p14:dur="2000">
         <p159:morph option="byObject"/>
       </p:transition>
     </mc:Choice>
-    <mc:Fallback>
+    <mc:Fallback xmlns="">
       <p:transition spd="slow">
         <p:fade/>
       </p:transition>
@@ -5300,7 +5366,7 @@
                 <a:ea typeface="Arial" pitchFamily="34" charset="-122"/>
                 <a:cs typeface="Arial" pitchFamily="34" charset="-120"/>
               </a:rPr>
-              <a:t>THE CHALLENGE</a:t>
+              <a:t>CHALLENGE TIME!!!</a:t>
             </a:r>
             <a:endParaRPr kumimoji="0" lang="en-US" sz="1300" b="0" i="0" u="none" strike="noStrike" kern="1200" cap="none" spc="0" normalizeH="0" baseline="0" noProof="0" dirty="0">
               <a:ln>
@@ -6383,8 +6449,8 @@
           </a:p>
         </p:txBody>
       </p:sp>
-      <mc:AlternateContent xmlns:mc="http://schemas.openxmlformats.org/markup-compatibility/2006">
-        <mc:Choice xmlns:a14="http://schemas.microsoft.com/office/drawing/2010/main" Requires="a14">
+      <mc:AlternateContent xmlns:mc="http://schemas.openxmlformats.org/markup-compatibility/2006" xmlns:a14="http://schemas.microsoft.com/office/drawing/2010/main">
+        <mc:Choice Requires="a14">
           <p:sp>
             <p:nvSpPr>
               <p:cNvPr id="20" name="TextBox 19">
@@ -6481,7 +6547,7 @@
             </p:txBody>
           </p:sp>
         </mc:Choice>
-        <mc:Fallback>
+        <mc:Fallback xmlns="">
           <p:sp>
             <p:nvSpPr>
               <p:cNvPr id="20" name="TextBox 19">
@@ -6526,6 +6592,36 @@
           </p:sp>
         </mc:Fallback>
       </mc:AlternateContent>
+      <p:pic>
+        <p:nvPicPr>
+          <p:cNvPr id="21" name="Picture 20" descr="Devious Blue Emoji">
+            <a:extLst>
+              <a:ext uri="{FF2B5EF4-FFF2-40B4-BE49-F238E27FC236}">
+                <a16:creationId xmlns:a16="http://schemas.microsoft.com/office/drawing/2014/main" id="{F54068A9-FB3F-85E7-0A8D-5B809ECA5939}"/>
+              </a:ext>
+            </a:extLst>
+          </p:cNvPr>
+          <p:cNvPicPr>
+            <a:picLocks noChangeAspect="1"/>
+          </p:cNvPicPr>
+          <p:nvPr/>
+        </p:nvPicPr>
+        <p:blipFill>
+          <a:blip r:embed="rId4"/>
+          <a:stretch>
+            <a:fillRect/>
+          </a:stretch>
+        </p:blipFill>
+        <p:spPr>
+          <a:xfrm>
+            <a:off x="8803113" y="121109"/>
+            <a:ext cx="2649747" cy="2649747"/>
+          </a:xfrm>
+          <a:prstGeom prst="rect">
+            <a:avLst/>
+          </a:prstGeom>
+        </p:spPr>
+      </p:pic>
     </p:spTree>
   </p:cSld>
   <p:clrMapOvr>
@@ -7717,7 +7813,7 @@
                 <a:ea typeface="Arial" pitchFamily="34" charset="-122"/>
                 <a:cs typeface="Arial" pitchFamily="34" charset="-120"/>
               </a:rPr>
-              <a:t>Import the VM — Ubuntu 22, ROS2 Humble, Gazebo</a:t>
+              <a:t>Import the VM; Ubuntu 22, ROS2 Humble, Gazebo</a:t>
             </a:r>
             <a:endParaRPr lang="en-US" sz="1250" dirty="0"/>
           </a:p>
@@ -9135,8 +9231,8 @@
   <p:clrMapOvr>
     <a:masterClrMapping/>
   </p:clrMapOvr>
-  <mc:AlternateContent xmlns:mc="http://schemas.openxmlformats.org/markup-compatibility/2006">
-    <mc:Choice xmlns:p15="http://schemas.microsoft.com/office/powerpoint/2012/main" Requires="p15">
+  <mc:AlternateContent xmlns:mc="http://schemas.openxmlformats.org/markup-compatibility/2006" xmlns:p15="http://schemas.microsoft.com/office/powerpoint/2012/main">
+    <mc:Choice Requires="p15">
       <p:transition xmlns:p14="http://schemas.microsoft.com/office/powerpoint/2010/main" spd="slow" p14:dur="2000">
         <p15:prstTrans prst="fracture"/>
         <p:sndAc>
@@ -9146,12 +9242,12 @@
         </p:sndAc>
       </p:transition>
     </mc:Choice>
-    <mc:Fallback>
+    <mc:Fallback xmlns="">
       <p:transition spd="slow">
         <p:fade/>
         <p:sndAc>
           <p:stSnd>
-            <p:snd r:embed="rId3" name="explode.wav"/>
+            <p:snd r:embed="rId4" name="explode.wav"/>
           </p:stSnd>
         </p:sndAc>
       </p:transition>
@@ -9961,6 +10057,130 @@
               <a:t>03</a:t>
             </a:r>
             <a:endParaRPr lang="en-US" sz="1000" dirty="0"/>
+          </a:p>
+        </p:txBody>
+      </p:sp>
+      <p:pic>
+        <p:nvPicPr>
+          <p:cNvPr id="23" name="Picture 22" descr="Computer Meme GIFs | Tenor">
+            <a:extLst>
+              <a:ext uri="{FF2B5EF4-FFF2-40B4-BE49-F238E27FC236}">
+                <a16:creationId xmlns:a16="http://schemas.microsoft.com/office/drawing/2014/main" id="{B81D0E7D-AF56-1670-B0A3-F890036C8ACF}"/>
+              </a:ext>
+            </a:extLst>
+          </p:cNvPr>
+          <p:cNvPicPr>
+            <a:picLocks noChangeAspect="1"/>
+          </p:cNvPicPr>
+          <p:nvPr/>
+        </p:nvPicPr>
+        <p:blipFill>
+          <a:blip r:embed="rId3"/>
+          <a:stretch>
+            <a:fillRect/>
+          </a:stretch>
+        </p:blipFill>
+        <p:spPr>
+          <a:xfrm>
+            <a:off x="6196297" y="1903505"/>
+            <a:ext cx="5163886" cy="2904686"/>
+          </a:xfrm>
+          <a:prstGeom prst="rect">
+            <a:avLst/>
+          </a:prstGeom>
+        </p:spPr>
+      </p:pic>
+      <p:sp>
+        <p:nvSpPr>
+          <p:cNvPr id="24" name="TextBox 23">
+            <a:extLst>
+              <a:ext uri="{FF2B5EF4-FFF2-40B4-BE49-F238E27FC236}">
+                <a16:creationId xmlns:a16="http://schemas.microsoft.com/office/drawing/2014/main" id="{D47DD1E5-D691-5AB2-5A0C-5F34993ED9DF}"/>
+              </a:ext>
+            </a:extLst>
+          </p:cNvPr>
+          <p:cNvSpPr txBox="1"/>
+          <p:nvPr/>
+        </p:nvSpPr>
+        <p:spPr>
+          <a:xfrm>
+            <a:off x="7116792" y="3831681"/>
+            <a:ext cx="1460656" cy="523220"/>
+          </a:xfrm>
+          <a:prstGeom prst="rect">
+            <a:avLst/>
+          </a:prstGeom>
+          <a:noFill/>
+        </p:spPr>
+        <p:txBody>
+          <a:bodyPr wrap="none" rtlCol="0">
+            <a:spAutoFit/>
+          </a:bodyPr>
+          <a:lstStyle/>
+          <a:p>
+            <a:r>
+              <a:rPr lang="en-AU" sz="2800" dirty="0">
+                <a:solidFill>
+                  <a:schemeClr val="bg1"/>
+                </a:solidFill>
+                <a:effectLst>
+                  <a:glow rad="228600">
+                    <a:schemeClr val="tx1">
+                      <a:alpha val="40000"/>
+                    </a:schemeClr>
+                  </a:glow>
+                </a:effectLst>
+                <a:latin typeface="Impact" panose="020B0806030902050204" pitchFamily="34" charset="0"/>
+              </a:rPr>
+              <a:t>UQ MARS</a:t>
+            </a:r>
+          </a:p>
+        </p:txBody>
+      </p:sp>
+      <p:sp>
+        <p:nvSpPr>
+          <p:cNvPr id="26" name="TextBox 25">
+            <a:extLst>
+              <a:ext uri="{FF2B5EF4-FFF2-40B4-BE49-F238E27FC236}">
+                <a16:creationId xmlns:a16="http://schemas.microsoft.com/office/drawing/2014/main" id="{7238CA04-86D5-0754-2A51-2DA0D0765A7F}"/>
+              </a:ext>
+            </a:extLst>
+          </p:cNvPr>
+          <p:cNvSpPr txBox="1"/>
+          <p:nvPr/>
+        </p:nvSpPr>
+        <p:spPr>
+          <a:xfrm>
+            <a:off x="9040398" y="3288995"/>
+            <a:ext cx="747320" cy="523220"/>
+          </a:xfrm>
+          <a:prstGeom prst="rect">
+            <a:avLst/>
+          </a:prstGeom>
+          <a:noFill/>
+        </p:spPr>
+        <p:txBody>
+          <a:bodyPr wrap="none" rtlCol="0">
+            <a:spAutoFit/>
+          </a:bodyPr>
+          <a:lstStyle/>
+          <a:p>
+            <a:r>
+              <a:rPr lang="en-AU" sz="2800" dirty="0">
+                <a:solidFill>
+                  <a:schemeClr val="bg1"/>
+                </a:solidFill>
+                <a:effectLst>
+                  <a:glow rad="228600">
+                    <a:schemeClr val="tx1">
+                      <a:alpha val="40000"/>
+                    </a:schemeClr>
+                  </a:glow>
+                </a:effectLst>
+                <a:latin typeface="Impact" panose="020B0806030902050204" pitchFamily="34" charset="0"/>
+              </a:rPr>
+              <a:t>YOU</a:t>
+            </a:r>
           </a:p>
         </p:txBody>
       </p:sp>
@@ -10472,6 +10692,24 @@
                 <a:cs typeface="Arial" pitchFamily="34" charset="-120"/>
               </a:rPr>
               <a:t>A named channel for exchanging messages. Nodes publish onto it, or subscribe to read from it.</a:t>
+            </a:r>
+          </a:p>
+          <a:p>
+            <a:pPr marL="0" indent="0">
+              <a:lnSpc>
+                <a:spcPct val="120000"/>
+              </a:lnSpc>
+              <a:buNone/>
+            </a:pPr>
+            <a:r>
+              <a:rPr lang="en-US" sz="1400" dirty="0">
+                <a:solidFill>
+                  <a:srgbClr val="3A4A66"/>
+                </a:solidFill>
+                <a:latin typeface="Arial" pitchFamily="34" charset="0"/>
+                <a:cs typeface="Arial" pitchFamily="34" charset="-120"/>
+              </a:rPr>
+              <a:t>(Think of it like a bulletin board)</a:t>
             </a:r>
             <a:endParaRPr lang="en-US" sz="1400" dirty="0"/>
           </a:p>
@@ -11276,6 +11514,36 @@
           </a:p>
         </p:txBody>
       </p:sp>
+      <p:pic>
+        <p:nvPicPr>
+          <p:cNvPr id="18" name="Picture 17" descr="Gigachad Source Trust Me Bro Funny Giga Chad Meme Magnet">
+            <a:extLst>
+              <a:ext uri="{FF2B5EF4-FFF2-40B4-BE49-F238E27FC236}">
+                <a16:creationId xmlns:a16="http://schemas.microsoft.com/office/drawing/2014/main" id="{C7F54B4B-629B-B7DF-203F-660732554C2B}"/>
+              </a:ext>
+            </a:extLst>
+          </p:cNvPr>
+          <p:cNvPicPr>
+            <a:picLocks noChangeAspect="1"/>
+          </p:cNvPicPr>
+          <p:nvPr/>
+        </p:nvPicPr>
+        <p:blipFill>
+          <a:blip r:embed="rId3"/>
+          <a:stretch>
+            <a:fillRect/>
+          </a:stretch>
+        </p:blipFill>
+        <p:spPr>
+          <a:xfrm>
+            <a:off x="8264106" y="2063051"/>
+            <a:ext cx="2597564" cy="3463418"/>
+          </a:xfrm>
+          <a:prstGeom prst="rect">
+            <a:avLst/>
+          </a:prstGeom>
+        </p:spPr>
+      </p:pic>
     </p:spTree>
   </p:cSld>
   <p:clrMapOvr>
@@ -11491,7 +11759,51 @@
                 <a:ea typeface="Consolas" pitchFamily="34" charset="-122"/>
                 <a:cs typeface="Consolas" pitchFamily="34" charset="-120"/>
               </a:rPr>
-              <a:t>cd ~/mars_ws/src/  &amp;&amp;  ros2 pkg create my_package</a:t>
+              <a:t>cd ~/mars_ws/src/  &amp;&amp;  ros2 pkg create </a:t>
+            </a:r>
+            <a:r>
+              <a:rPr lang="en-AU" sz="1500" dirty="0">
+                <a:solidFill>
+                  <a:srgbClr val="18C7B8"/>
+                </a:solidFill>
+                <a:latin typeface="Consolas" pitchFamily="34" charset="0"/>
+                <a:ea typeface="Consolas" pitchFamily="34" charset="-122"/>
+                <a:cs typeface="Consolas" pitchFamily="34" charset="-120"/>
+              </a:rPr>
+              <a:t>--build-type </a:t>
+            </a:r>
+            <a:r>
+              <a:rPr lang="en-AU" sz="1500" dirty="0" err="1">
+                <a:solidFill>
+                  <a:srgbClr val="18C7B8"/>
+                </a:solidFill>
+                <a:latin typeface="Consolas" pitchFamily="34" charset="0"/>
+                <a:ea typeface="Consolas" pitchFamily="34" charset="-122"/>
+                <a:cs typeface="Consolas" pitchFamily="34" charset="-120"/>
+              </a:rPr>
+              <a:t>ament_python</a:t>
+            </a:r>
+            <a:r>
+              <a:rPr lang="en-AU" sz="1500" dirty="0">
+                <a:solidFill>
+                  <a:srgbClr val="18C7B8"/>
+                </a:solidFill>
+                <a:latin typeface="Consolas" pitchFamily="34" charset="0"/>
+                <a:ea typeface="Consolas" pitchFamily="34" charset="-122"/>
+                <a:cs typeface="Consolas" pitchFamily="34" charset="-120"/>
+              </a:rPr>
+              <a:t> </a:t>
+            </a:r>
+            <a:r>
+              <a:rPr lang="en-AU" sz="1500" dirty="0" err="1">
+                <a:solidFill>
+                  <a:srgbClr val="18C7B8"/>
+                </a:solidFill>
+                <a:latin typeface="Consolas" pitchFamily="34" charset="0"/>
+                <a:ea typeface="Consolas" pitchFamily="34" charset="-122"/>
+                <a:cs typeface="Consolas" pitchFamily="34" charset="-120"/>
+              </a:rPr>
+              <a:t>my_package</a:t>
             </a:r>
             <a:endParaRPr lang="en-US" sz="1500" dirty="0"/>
           </a:p>
@@ -12003,18 +12315,48 @@
           </a:p>
         </p:txBody>
       </p:sp>
+      <p:pic>
+        <p:nvPicPr>
+          <p:cNvPr id="21" name="Picture 20" descr="Nice Package GIFs | Tenor">
+            <a:extLst>
+              <a:ext uri="{FF2B5EF4-FFF2-40B4-BE49-F238E27FC236}">
+                <a16:creationId xmlns:a16="http://schemas.microsoft.com/office/drawing/2014/main" id="{D45179B4-AB17-27BD-4F37-CCAD2C4BFEFB}"/>
+              </a:ext>
+            </a:extLst>
+          </p:cNvPr>
+          <p:cNvPicPr>
+            <a:picLocks noChangeAspect="1"/>
+          </p:cNvPicPr>
+          <p:nvPr/>
+        </p:nvPicPr>
+        <p:blipFill>
+          <a:blip r:embed="rId3"/>
+          <a:stretch>
+            <a:fillRect/>
+          </a:stretch>
+        </p:blipFill>
+        <p:spPr>
+          <a:xfrm>
+            <a:off x="7872458" y="3020244"/>
+            <a:ext cx="3557542" cy="2957207"/>
+          </a:xfrm>
+          <a:prstGeom prst="rect">
+            <a:avLst/>
+          </a:prstGeom>
+        </p:spPr>
+      </p:pic>
     </p:spTree>
   </p:cSld>
   <p:clrMapOvr>
     <a:masterClrMapping/>
   </p:clrMapOvr>
-  <mc:AlternateContent xmlns:mc="http://schemas.openxmlformats.org/markup-compatibility/2006">
-    <mc:Choice xmlns:p159="http://schemas.microsoft.com/office/powerpoint/2015/09/main" Requires="p159">
+  <mc:AlternateContent xmlns:mc="http://schemas.openxmlformats.org/markup-compatibility/2006" xmlns:p159="http://schemas.microsoft.com/office/powerpoint/2015/09/main">
+    <mc:Choice Requires="p159">
       <p:transition xmlns:p14="http://schemas.microsoft.com/office/powerpoint/2010/main" spd="slow" p14:dur="2000">
         <p159:morph option="byObject"/>
       </p:transition>
     </mc:Choice>
-    <mc:Fallback>
+    <mc:Fallback xmlns="">
       <p:transition spd="slow">
         <p:fade/>
       </p:transition>
@@ -12542,18 +12884,101 @@
           </a:p>
         </p:txBody>
       </p:sp>
+      <p:pic>
+        <p:nvPicPr>
+          <p:cNvPr id="10" name="Picture 9" descr="Microsoft Publisher - Wikipedia">
+            <a:extLst>
+              <a:ext uri="{FF2B5EF4-FFF2-40B4-BE49-F238E27FC236}">
+                <a16:creationId xmlns:a16="http://schemas.microsoft.com/office/drawing/2014/main" id="{E2569C46-E66D-CB11-4035-F2C2637B5B74}"/>
+              </a:ext>
+            </a:extLst>
+          </p:cNvPr>
+          <p:cNvPicPr>
+            <a:picLocks noChangeAspect="1"/>
+          </p:cNvPicPr>
+          <p:nvPr/>
+        </p:nvPicPr>
+        <p:blipFill>
+          <a:blip r:embed="rId3"/>
+          <a:stretch>
+            <a:fillRect/>
+          </a:stretch>
+        </p:blipFill>
+        <p:spPr>
+          <a:xfrm>
+            <a:off x="8999220" y="457200"/>
+            <a:ext cx="2225040" cy="1994050"/>
+          </a:xfrm>
+          <a:prstGeom prst="rect">
+            <a:avLst/>
+          </a:prstGeom>
+        </p:spPr>
+      </p:pic>
+      <p:sp>
+        <p:nvSpPr>
+          <p:cNvPr id="11" name="&quot;Not Allowed&quot; Symbol 10">
+            <a:extLst>
+              <a:ext uri="{FF2B5EF4-FFF2-40B4-BE49-F238E27FC236}">
+                <a16:creationId xmlns:a16="http://schemas.microsoft.com/office/drawing/2014/main" id="{9138088A-4A4D-7E22-115B-601CB23625C6}"/>
+              </a:ext>
+            </a:extLst>
+          </p:cNvPr>
+          <p:cNvSpPr/>
+          <p:nvPr/>
+        </p:nvSpPr>
+        <p:spPr>
+          <a:xfrm>
+            <a:off x="8571206" y="321765"/>
+            <a:ext cx="2904514" cy="2191109"/>
+          </a:xfrm>
+          <a:prstGeom prst="noSmoking">
+            <a:avLst/>
+          </a:prstGeom>
+          <a:solidFill>
+            <a:srgbClr val="FF0000"/>
+          </a:solidFill>
+        </p:spPr>
+        <p:style>
+          <a:lnRef idx="2">
+            <a:schemeClr val="accent1">
+              <a:shade val="15000"/>
+            </a:schemeClr>
+          </a:lnRef>
+          <a:fillRef idx="1">
+            <a:schemeClr val="accent1"/>
+          </a:fillRef>
+          <a:effectRef idx="0">
+            <a:schemeClr val="accent1"/>
+          </a:effectRef>
+          <a:fontRef idx="minor">
+            <a:schemeClr val="lt1"/>
+          </a:fontRef>
+        </p:style>
+        <p:txBody>
+          <a:bodyPr rtlCol="0" anchor="ctr"/>
+          <a:lstStyle/>
+          <a:p>
+            <a:pPr algn="ctr"/>
+            <a:endParaRPr lang="en-AU">
+              <a:solidFill>
+                <a:schemeClr val="tx1"/>
+              </a:solidFill>
+            </a:endParaRPr>
+          </a:p>
+        </p:txBody>
+      </p:sp>
     </p:spTree>
   </p:cSld>
   <p:clrMapOvr>
     <a:masterClrMapping/>
   </p:clrMapOvr>
-  <mc:AlternateContent xmlns:mc="http://schemas.openxmlformats.org/markup-compatibility/2006">
-    <mc:Choice xmlns:p159="http://schemas.microsoft.com/office/powerpoint/2015/09/main" Requires="p159">
+  <mc:AlternateContent xmlns:mc="http://schemas.openxmlformats.org/markup-compatibility/2006" xmlns:p159="http://schemas.microsoft.com/office/powerpoint/2015/09/main">
+    <mc:Choice Requires="p159">
       <p:transition xmlns:p14="http://schemas.microsoft.com/office/powerpoint/2010/main" spd="slow" p14:dur="2000">
         <p159:morph option="byObject"/>
       </p:transition>
     </mc:Choice>
-    <mc:Fallback>
+    <mc:Fallback xmlns="">
       <p:transition spd="slow">
         <p:fade/>
       </p:transition>
@@ -13031,18 +13456,48 @@
           </a:p>
         </p:txBody>
       </p:sp>
+      <p:pic>
+        <p:nvPicPr>
+          <p:cNvPr id="11" name="Picture 10">
+            <a:extLst>
+              <a:ext uri="{FF2B5EF4-FFF2-40B4-BE49-F238E27FC236}">
+                <a16:creationId xmlns:a16="http://schemas.microsoft.com/office/drawing/2014/main" id="{EF64974A-A18C-50D0-7D93-D952A27C848D}"/>
+              </a:ext>
+            </a:extLst>
+          </p:cNvPr>
+          <p:cNvPicPr>
+            <a:picLocks noChangeAspect="1"/>
+          </p:cNvPicPr>
+          <p:nvPr/>
+        </p:nvPicPr>
+        <p:blipFill>
+          <a:blip r:embed="rId3"/>
+          <a:stretch>
+            <a:fillRect/>
+          </a:stretch>
+        </p:blipFill>
+        <p:spPr>
+          <a:xfrm>
+            <a:off x="7550126" y="1761487"/>
+            <a:ext cx="3514114" cy="3152145"/>
+          </a:xfrm>
+          <a:prstGeom prst="rect">
+            <a:avLst/>
+          </a:prstGeom>
+        </p:spPr>
+      </p:pic>
     </p:spTree>
   </p:cSld>
   <p:clrMapOvr>
     <a:masterClrMapping/>
   </p:clrMapOvr>
-  <mc:AlternateContent xmlns:mc="http://schemas.openxmlformats.org/markup-compatibility/2006">
-    <mc:Choice xmlns:p159="http://schemas.microsoft.com/office/powerpoint/2015/09/main" Requires="p159">
+  <mc:AlternateContent xmlns:mc="http://schemas.openxmlformats.org/markup-compatibility/2006" xmlns:p159="http://schemas.microsoft.com/office/powerpoint/2015/09/main">
+    <mc:Choice Requires="p159">
       <p:transition xmlns:p14="http://schemas.microsoft.com/office/powerpoint/2010/main" spd="slow" p14:dur="2000">
         <p159:morph option="byObject"/>
       </p:transition>
     </mc:Choice>
-    <mc:Fallback>
+    <mc:Fallback xmlns="">
       <p:transition spd="slow">
         <p:fade/>
       </p:transition>
@@ -13751,23 +14206,315 @@
           </a:p>
         </p:txBody>
       </p:sp>
+      <p:cxnSp>
+        <p:nvCxnSpPr>
+          <p:cNvPr id="30" name="Connector: Curved 29">
+            <a:extLst>
+              <a:ext uri="{FF2B5EF4-FFF2-40B4-BE49-F238E27FC236}">
+                <a16:creationId xmlns:a16="http://schemas.microsoft.com/office/drawing/2014/main" id="{124CCD3D-5A22-0D89-1294-D659B89F3C9E}"/>
+              </a:ext>
+            </a:extLst>
+          </p:cNvPr>
+          <p:cNvCxnSpPr>
+            <a:cxnSpLocks/>
+            <a:endCxn id="38" idx="2"/>
+          </p:cNvCxnSpPr>
+          <p:nvPr/>
+        </p:nvCxnSpPr>
+        <p:spPr>
+          <a:xfrm flipV="1">
+            <a:off x="5650301" y="2221421"/>
+            <a:ext cx="4042339" cy="1859294"/>
+          </a:xfrm>
+          <a:prstGeom prst="curvedConnector4">
+            <a:avLst>
+              <a:gd name="adj1" fmla="val 8188"/>
+              <a:gd name="adj2" fmla="val 57712"/>
+            </a:avLst>
+          </a:prstGeom>
+          <a:ln w="57150">
+            <a:tailEnd type="triangle"/>
+          </a:ln>
+        </p:spPr>
+        <p:style>
+          <a:lnRef idx="2">
+            <a:schemeClr val="accent2"/>
+          </a:lnRef>
+          <a:fillRef idx="0">
+            <a:schemeClr val="accent2"/>
+          </a:fillRef>
+          <a:effectRef idx="1">
+            <a:schemeClr val="accent2"/>
+          </a:effectRef>
+          <a:fontRef idx="minor">
+            <a:schemeClr val="tx1"/>
+          </a:fontRef>
+        </p:style>
+      </p:cxnSp>
+      <p:sp>
+        <p:nvSpPr>
+          <p:cNvPr id="38" name="Scroll: Horizontal 37">
+            <a:extLst>
+              <a:ext uri="{FF2B5EF4-FFF2-40B4-BE49-F238E27FC236}">
+                <a16:creationId xmlns:a16="http://schemas.microsoft.com/office/drawing/2014/main" id="{552DB2FE-9E9F-A916-7635-8C74E8F8A4CB}"/>
+              </a:ext>
+            </a:extLst>
+          </p:cNvPr>
+          <p:cNvSpPr/>
+          <p:nvPr/>
+        </p:nvSpPr>
+        <p:spPr>
+          <a:xfrm>
+            <a:off x="7571692" y="329184"/>
+            <a:ext cx="4241896" cy="2162556"/>
+          </a:xfrm>
+          <a:prstGeom prst="horizontalScroll">
+            <a:avLst/>
+          </a:prstGeom>
+        </p:spPr>
+        <p:style>
+          <a:lnRef idx="2">
+            <a:schemeClr val="accent2">
+              <a:shade val="15000"/>
+            </a:schemeClr>
+          </a:lnRef>
+          <a:fillRef idx="1">
+            <a:schemeClr val="accent2"/>
+          </a:fillRef>
+          <a:effectRef idx="0">
+            <a:schemeClr val="accent2"/>
+          </a:effectRef>
+          <a:fontRef idx="minor">
+            <a:schemeClr val="lt1"/>
+          </a:fontRef>
+        </p:style>
+        <p:txBody>
+          <a:bodyPr rtlCol="0" anchor="ctr"/>
+          <a:lstStyle/>
+          <a:p>
+            <a:pPr algn="ctr"/>
+            <a:r>
+              <a:rPr lang="en-AU" dirty="0">
+                <a:solidFill>
+                  <a:schemeClr val="tx1">
+                    <a:lumMod val="85000"/>
+                    <a:lumOff val="15000"/>
+                  </a:schemeClr>
+                </a:solidFill>
+                <a:latin typeface="Arial" panose="020B0604020202020204" pitchFamily="34" charset="0"/>
+                <a:cs typeface="Arial" panose="020B0604020202020204" pitchFamily="34" charset="0"/>
+              </a:rPr>
+              <a:t>Using </a:t>
+            </a:r>
+            <a:r>
+              <a:rPr lang="en-AU" b="1" dirty="0">
+                <a:solidFill>
+                  <a:schemeClr val="tx1">
+                    <a:lumMod val="85000"/>
+                    <a:lumOff val="15000"/>
+                  </a:schemeClr>
+                </a:solidFill>
+                <a:latin typeface="Courier New" panose="02070309020205020404" pitchFamily="49" charset="0"/>
+                <a:cs typeface="Courier New" panose="02070309020205020404" pitchFamily="49" charset="0"/>
+              </a:rPr>
+              <a:t>‘--</a:t>
+            </a:r>
+            <a:r>
+              <a:rPr lang="en-AU" b="1" dirty="0" err="1">
+                <a:solidFill>
+                  <a:schemeClr val="tx1">
+                    <a:lumMod val="85000"/>
+                    <a:lumOff val="15000"/>
+                  </a:schemeClr>
+                </a:solidFill>
+                <a:latin typeface="Courier New" panose="02070309020205020404" pitchFamily="49" charset="0"/>
+                <a:cs typeface="Courier New" panose="02070309020205020404" pitchFamily="49" charset="0"/>
+              </a:rPr>
+              <a:t>symlink</a:t>
+            </a:r>
+            <a:r>
+              <a:rPr lang="en-AU" b="1" dirty="0">
+                <a:solidFill>
+                  <a:schemeClr val="tx1">
+                    <a:lumMod val="85000"/>
+                    <a:lumOff val="15000"/>
+                  </a:schemeClr>
+                </a:solidFill>
+                <a:latin typeface="Courier New" panose="02070309020205020404" pitchFamily="49" charset="0"/>
+                <a:cs typeface="Courier New" panose="02070309020205020404" pitchFamily="49" charset="0"/>
+              </a:rPr>
+              <a:t>-install’ </a:t>
+            </a:r>
+            <a:r>
+              <a:rPr lang="en-AU" dirty="0">
+                <a:solidFill>
+                  <a:schemeClr val="tx1">
+                    <a:lumMod val="85000"/>
+                    <a:lumOff val="15000"/>
+                  </a:schemeClr>
+                </a:solidFill>
+                <a:latin typeface="Arial" panose="020B0604020202020204" pitchFamily="34" charset="0"/>
+                <a:cs typeface="Arial" panose="020B0604020202020204" pitchFamily="34" charset="0"/>
+              </a:rPr>
+              <a:t>means you can make changes in Python scripts or configuration files take without needing a full rebuild!</a:t>
+            </a:r>
+          </a:p>
+          <a:p>
+            <a:pPr algn="ctr"/>
+            <a:endParaRPr lang="en-AU" dirty="0">
+              <a:latin typeface="Arial" panose="020B0604020202020204" pitchFamily="34" charset="0"/>
+              <a:cs typeface="Arial" panose="020B0604020202020204" pitchFamily="34" charset="0"/>
+            </a:endParaRPr>
+          </a:p>
+        </p:txBody>
+      </p:sp>
     </p:spTree>
   </p:cSld>
   <p:clrMapOvr>
     <a:masterClrMapping/>
   </p:clrMapOvr>
-  <mc:AlternateContent xmlns:mc="http://schemas.openxmlformats.org/markup-compatibility/2006">
-    <mc:Choice xmlns:p159="http://schemas.microsoft.com/office/powerpoint/2015/09/main" Requires="p159">
+  <mc:AlternateContent xmlns:mc="http://schemas.openxmlformats.org/markup-compatibility/2006" xmlns:p159="http://schemas.microsoft.com/office/powerpoint/2015/09/main">
+    <mc:Choice Requires="p159">
       <p:transition xmlns:p14="http://schemas.microsoft.com/office/powerpoint/2010/main" spd="slow" p14:dur="2000">
         <p159:morph option="byObject"/>
       </p:transition>
     </mc:Choice>
-    <mc:Fallback>
+    <mc:Fallback xmlns="">
       <p:transition spd="slow">
         <p:fade/>
       </p:transition>
     </mc:Fallback>
   </mc:AlternateContent>
+  <p:timing>
+    <p:tnLst>
+      <p:par>
+        <p:cTn id="1" dur="indefinite" restart="never" nodeType="tmRoot">
+          <p:childTnLst>
+            <p:seq concurrent="1" nextAc="seek">
+              <p:cTn id="2" dur="indefinite" nodeType="mainSeq">
+                <p:childTnLst>
+                  <p:par>
+                    <p:cTn id="3" fill="hold">
+                      <p:stCondLst>
+                        <p:cond delay="indefinite"/>
+                      </p:stCondLst>
+                      <p:childTnLst>
+                        <p:par>
+                          <p:cTn id="4" fill="hold">
+                            <p:stCondLst>
+                              <p:cond delay="0"/>
+                            </p:stCondLst>
+                            <p:childTnLst>
+                              <p:par>
+                                <p:cTn id="5" presetID="22" presetClass="entr" presetSubtype="4" fill="hold" nodeType="clickEffect">
+                                  <p:stCondLst>
+                                    <p:cond delay="0"/>
+                                  </p:stCondLst>
+                                  <p:childTnLst>
+                                    <p:set>
+                                      <p:cBhvr>
+                                        <p:cTn id="6" dur="1" fill="hold">
+                                          <p:stCondLst>
+                                            <p:cond delay="0"/>
+                                          </p:stCondLst>
+                                        </p:cTn>
+                                        <p:tgtEl>
+                                          <p:spTgt spid="30"/>
+                                        </p:tgtEl>
+                                        <p:attrNameLst>
+                                          <p:attrName>style.visibility</p:attrName>
+                                        </p:attrNameLst>
+                                      </p:cBhvr>
+                                      <p:to>
+                                        <p:strVal val="visible"/>
+                                      </p:to>
+                                    </p:set>
+                                    <p:animEffect transition="in" filter="wipe(down)">
+                                      <p:cBhvr>
+                                        <p:cTn id="7" dur="500"/>
+                                        <p:tgtEl>
+                                          <p:spTgt spid="30"/>
+                                        </p:tgtEl>
+                                      </p:cBhvr>
+                                    </p:animEffect>
+                                  </p:childTnLst>
+                                </p:cTn>
+                              </p:par>
+                            </p:childTnLst>
+                          </p:cTn>
+                        </p:par>
+                        <p:par>
+                          <p:cTn id="8" fill="hold">
+                            <p:stCondLst>
+                              <p:cond delay="500"/>
+                            </p:stCondLst>
+                            <p:childTnLst>
+                              <p:par>
+                                <p:cTn id="9" presetID="21" presetClass="entr" presetSubtype="1" fill="hold" grpId="0" nodeType="afterEffect">
+                                  <p:stCondLst>
+                                    <p:cond delay="0"/>
+                                  </p:stCondLst>
+                                  <p:childTnLst>
+                                    <p:set>
+                                      <p:cBhvr>
+                                        <p:cTn id="10" dur="1" fill="hold">
+                                          <p:stCondLst>
+                                            <p:cond delay="0"/>
+                                          </p:stCondLst>
+                                        </p:cTn>
+                                        <p:tgtEl>
+                                          <p:spTgt spid="38"/>
+                                        </p:tgtEl>
+                                        <p:attrNameLst>
+                                          <p:attrName>style.visibility</p:attrName>
+                                        </p:attrNameLst>
+                                      </p:cBhvr>
+                                      <p:to>
+                                        <p:strVal val="visible"/>
+                                      </p:to>
+                                    </p:set>
+                                    <p:animEffect transition="in" filter="wheel(1)">
+                                      <p:cBhvr>
+                                        <p:cTn id="11" dur="2000"/>
+                                        <p:tgtEl>
+                                          <p:spTgt spid="38"/>
+                                        </p:tgtEl>
+                                      </p:cBhvr>
+                                    </p:animEffect>
+                                  </p:childTnLst>
+                                </p:cTn>
+                              </p:par>
+                            </p:childTnLst>
+                          </p:cTn>
+                        </p:par>
+                      </p:childTnLst>
+                    </p:cTn>
+                  </p:par>
+                </p:childTnLst>
+              </p:cTn>
+              <p:prevCondLst>
+                <p:cond evt="onPrev" delay="0">
+                  <p:tgtEl>
+                    <p:sldTgt/>
+                  </p:tgtEl>
+                </p:cond>
+              </p:prevCondLst>
+              <p:nextCondLst>
+                <p:cond evt="onNext" delay="0">
+                  <p:tgtEl>
+                    <p:sldTgt/>
+                  </p:tgtEl>
+                </p:cond>
+              </p:nextCondLst>
+            </p:seq>
+          </p:childTnLst>
+        </p:cTn>
+      </p:par>
+    </p:tnLst>
+    <p:bldLst>
+      <p:bldP spid="38" grpId="0" animBg="1"/>
+    </p:bldLst>
+  </p:timing>
 </p:sld>
 </file>
 

</xml_diff>